<commit_message>
updating class 9 and 10
</commit_message>
<xml_diff>
--- a/docs/lectures/in-class_activities/class_10.pptx
+++ b/docs/lectures/in-class_activities/class_10.pptx
@@ -207,7 +207,7 @@
           <a:p>
             <a:fld id="{6AC7DB66-C6D6-B24E-B345-FA3772C924EA}" type="datetimeFigureOut">
               <a:rPr lang="en-US" smtClean="0"/>
-              <a:t>10/20/25</a:t>
+              <a:t>10/23/26</a:t>
             </a:fld>
             <a:endParaRPr lang="en-US"/>
           </a:p>
@@ -1578,7 +1578,7 @@
           <a:p>
             <a:fld id="{21DDE3A9-9D48-7D40-AF95-520AE186EA5D}" type="datetimeFigureOut">
               <a:rPr lang="en-US" smtClean="0"/>
-              <a:t>10/20/25</a:t>
+              <a:t>10/23/26</a:t>
             </a:fld>
             <a:endParaRPr lang="en-US"/>
           </a:p>
@@ -1776,7 +1776,7 @@
           <a:p>
             <a:fld id="{21DDE3A9-9D48-7D40-AF95-520AE186EA5D}" type="datetimeFigureOut">
               <a:rPr lang="en-US" smtClean="0"/>
-              <a:t>10/20/25</a:t>
+              <a:t>10/23/26</a:t>
             </a:fld>
             <a:endParaRPr lang="en-US"/>
           </a:p>
@@ -1984,7 +1984,7 @@
           <a:p>
             <a:fld id="{21DDE3A9-9D48-7D40-AF95-520AE186EA5D}" type="datetimeFigureOut">
               <a:rPr lang="en-US" smtClean="0"/>
-              <a:t>10/20/25</a:t>
+              <a:t>10/23/26</a:t>
             </a:fld>
             <a:endParaRPr lang="en-US"/>
           </a:p>
@@ -2182,7 +2182,7 @@
           <a:p>
             <a:fld id="{21DDE3A9-9D48-7D40-AF95-520AE186EA5D}" type="datetimeFigureOut">
               <a:rPr lang="en-US" smtClean="0"/>
-              <a:t>10/20/25</a:t>
+              <a:t>10/23/26</a:t>
             </a:fld>
             <a:endParaRPr lang="en-US"/>
           </a:p>
@@ -2457,7 +2457,7 @@
           <a:p>
             <a:fld id="{21DDE3A9-9D48-7D40-AF95-520AE186EA5D}" type="datetimeFigureOut">
               <a:rPr lang="en-US" smtClean="0"/>
-              <a:t>10/20/25</a:t>
+              <a:t>10/23/26</a:t>
             </a:fld>
             <a:endParaRPr lang="en-US"/>
           </a:p>
@@ -2722,7 +2722,7 @@
           <a:p>
             <a:fld id="{21DDE3A9-9D48-7D40-AF95-520AE186EA5D}" type="datetimeFigureOut">
               <a:rPr lang="en-US" smtClean="0"/>
-              <a:t>10/20/25</a:t>
+              <a:t>10/23/26</a:t>
             </a:fld>
             <a:endParaRPr lang="en-US"/>
           </a:p>
@@ -3134,7 +3134,7 @@
           <a:p>
             <a:fld id="{21DDE3A9-9D48-7D40-AF95-520AE186EA5D}" type="datetimeFigureOut">
               <a:rPr lang="en-US" smtClean="0"/>
-              <a:t>10/20/25</a:t>
+              <a:t>10/23/26</a:t>
             </a:fld>
             <a:endParaRPr lang="en-US"/>
           </a:p>
@@ -3275,7 +3275,7 @@
           <a:p>
             <a:fld id="{21DDE3A9-9D48-7D40-AF95-520AE186EA5D}" type="datetimeFigureOut">
               <a:rPr lang="en-US" smtClean="0"/>
-              <a:t>10/20/25</a:t>
+              <a:t>10/23/26</a:t>
             </a:fld>
             <a:endParaRPr lang="en-US"/>
           </a:p>
@@ -3388,7 +3388,7 @@
           <a:p>
             <a:fld id="{21DDE3A9-9D48-7D40-AF95-520AE186EA5D}" type="datetimeFigureOut">
               <a:rPr lang="en-US" smtClean="0"/>
-              <a:t>10/20/25</a:t>
+              <a:t>10/23/26</a:t>
             </a:fld>
             <a:endParaRPr lang="en-US"/>
           </a:p>
@@ -3699,7 +3699,7 @@
           <a:p>
             <a:fld id="{21DDE3A9-9D48-7D40-AF95-520AE186EA5D}" type="datetimeFigureOut">
               <a:rPr lang="en-US" smtClean="0"/>
-              <a:t>10/20/25</a:t>
+              <a:t>10/23/26</a:t>
             </a:fld>
             <a:endParaRPr lang="en-US"/>
           </a:p>
@@ -3987,7 +3987,7 @@
           <a:p>
             <a:fld id="{21DDE3A9-9D48-7D40-AF95-520AE186EA5D}" type="datetimeFigureOut">
               <a:rPr lang="en-US" smtClean="0"/>
-              <a:t>10/20/25</a:t>
+              <a:t>10/23/26</a:t>
             </a:fld>
             <a:endParaRPr lang="en-US"/>
           </a:p>
@@ -4228,7 +4228,7 @@
           <a:p>
             <a:fld id="{21DDE3A9-9D48-7D40-AF95-520AE186EA5D}" type="datetimeFigureOut">
               <a:rPr lang="en-US" smtClean="0"/>
-              <a:t>10/20/25</a:t>
+              <a:t>10/23/26</a:t>
             </a:fld>
             <a:endParaRPr lang="en-US"/>
           </a:p>
@@ -5413,7 +5413,7 @@
                 <a:latin typeface="Avenir"/>
                 <a:cs typeface="Avenir"/>
               </a:rPr>
-              <a:t>Ponder on your own (3 m), discuss with your group (5 m), then share with the class (5 m).</a:t>
+              <a:t>Ponder on your own (2 m), discuss with your group (3 m), then share with the class (5 m).</a:t>
             </a:r>
           </a:p>
         </p:txBody>

</xml_diff>